<commit_message>
Deck: clickable GitHub repo link on slides 2 and 6
Co-Authored-By: Claude Opus 5.5 <noreply@anthropic.com>
</commit_message>
<xml_diff>
--- a/presentation/SIH26063_Polar_Knowledge_Index.pptx
+++ b/presentation/SIH26063_Polar_Knowledge_Index.pptx
@@ -9084,8 +9084,8 @@
         </p:nvSpPr>
         <p:spPr>
           <a:xfrm>
-            <a:off x="8001000" y="6053328"/>
-            <a:ext cx="3840480" cy="274320"/>
+            <a:off x="8001000" y="6035040"/>
+            <a:ext cx="3840480" cy="310896"/>
           </a:xfrm>
           <a:prstGeom prst="rect">
             <a:avLst/>
@@ -9104,29 +9104,39 @@
               </a:spcAft>
             </a:pPr>
             <a:r>
-              <a:rPr sz="850" b="1" i="0" u="none">
+              <a:rPr sz="800" b="1" i="0" u="none">
                 <a:solidFill>
                   <a:srgbClr val="1F2937"/>
                 </a:solidFill>
                 <a:latin typeface="Calibri"/>
               </a:rPr>
-              <a:t>github repo link :</a:t>
-            </a:r>
-          </a:p>
-          <a:p>
-            <a:pPr algn="l">
+              <a:t>github repo link : </a:t>
+            </a:r>
+            <a:r>
+              <a:rPr sz="800" u="sng">
+                <a:solidFill>
+                  <a:srgbClr val="1F6FD1"/>
+                </a:solidFill>
+                <a:latin typeface="Calibri"/>
+                <a:hlinkClick r:id="rId19"/>
+              </a:rPr>
+              <a:t>https://github.com/saransh2809/SIH26063-Polar-Knowledge-Index</a:t>
+            </a:r>
+          </a:p>
+          <a:p>
+            <a:pPr>
               <a:spcAft>
                 <a:spcPts val="0"/>
               </a:spcAft>
             </a:pPr>
             <a:r>
-              <a:rPr sz="850" b="1" i="0" u="none">
+              <a:rPr sz="800" b="1" i="0" u="none">
                 <a:solidFill>
                   <a:srgbClr val="1F2937"/>
                 </a:solidFill>
                 <a:latin typeface="Calibri"/>
               </a:rPr>
-              <a:t>demo youtube video :</a:t>
+              <a:t>demo youtube video : </a:t>
             </a:r>
           </a:p>
         </p:txBody>
@@ -19057,8 +19067,8 @@
         </p:nvSpPr>
         <p:spPr>
           <a:xfrm>
-            <a:off x="320040" y="6053328"/>
-            <a:ext cx="5760720" cy="274320"/>
+            <a:off x="320040" y="6035040"/>
+            <a:ext cx="5760720" cy="310896"/>
           </a:xfrm>
           <a:prstGeom prst="rect">
             <a:avLst/>
@@ -19073,7 +19083,7 @@
           <a:p>
             <a:pPr algn="l">
               <a:spcAft>
-                <a:spcPts val="200"/>
+                <a:spcPts val="0"/>
               </a:spcAft>
             </a:pPr>
             <a:r>
@@ -19083,25 +19093,33 @@
                 </a:solidFill>
                 <a:latin typeface="Calibri"/>
               </a:rPr>
-              <a:t>github repo link :</a:t>
-            </a:r>
-            <a:r>
-              <a:rPr sz="850" b="0" i="0" u="none">
+              <a:t>github repo link : </a:t>
+            </a:r>
+            <a:r>
+              <a:rPr sz="850" u="sng">
+                <a:solidFill>
+                  <a:srgbClr val="1F6FD1"/>
+                </a:solidFill>
+                <a:latin typeface="Calibri"/>
+                <a:hlinkClick r:id="rId16"/>
+              </a:rPr>
+              <a:t>https://github.com/saransh2809/SIH26063-Polar-Knowledge-Index</a:t>
+            </a:r>
+          </a:p>
+          <a:p>
+            <a:pPr>
+              <a:spcAft>
+                <a:spcPts val="0"/>
+              </a:spcAft>
+            </a:pPr>
+            <a:r>
+              <a:rPr sz="850" b="1" i="0" u="none">
                 <a:solidFill>
                   <a:srgbClr val="1F2937"/>
                 </a:solidFill>
                 <a:latin typeface="Calibri"/>
               </a:rPr>
-              <a:t>   </a:t>
-            </a:r>
-            <a:r>
-              <a:rPr sz="850" b="1" i="0" u="none">
-                <a:solidFill>
-                  <a:srgbClr val="1F2937"/>
-                </a:solidFill>
-                <a:latin typeface="Calibri"/>
-              </a:rPr>
-              <a:t>demo youtube video :</a:t>
+              <a:t>demo youtube video : </a:t>
             </a:r>
           </a:p>
         </p:txBody>
@@ -19159,7 +19177,7 @@
           <p:nvPr/>
         </p:nvPicPr>
         <p:blipFill>
-          <a:blip r:embed="rId16"/>
+          <a:blip r:embed="rId17"/>
           <a:stretch>
             <a:fillRect/>
           </a:stretch>

</xml_diff>